<commit_message>
Updated french figures as well as proof read the translation output
</commit_message>
<xml_diff>
--- a/Borealis infosheet/Figures/Figures for Borealis document.pptx
+++ b/Borealis infosheet/Figures/Figures for Borealis document.pptx
@@ -117,6 +117,11 @@
             <a:srgbClr val="A4A3A4"/>
           </p15:clr>
         </p15:guide>
+        <p15:guide id="3" orient="horz" pos="9102">
+          <p15:clr>
+            <a:srgbClr val="A4A3A4"/>
+          </p15:clr>
+        </p15:guide>
       </p15:sldGuideLst>
     </p:ext>
   </p:extLst>
@@ -254,7 +259,7 @@
           <a:p>
             <a:fld id="{BB28D876-8156-7A44-AEE1-4802FB0B213F}" type="datetimeFigureOut">
               <a:rPr lang="en-CA" smtClean="0"/>
-              <a:t>2025-05-08</a:t>
+              <a:t>2025-08-20</a:t>
             </a:fld>
             <a:endParaRPr lang="en-CA"/>
           </a:p>
@@ -424,7 +429,7 @@
           <a:p>
             <a:fld id="{BB28D876-8156-7A44-AEE1-4802FB0B213F}" type="datetimeFigureOut">
               <a:rPr lang="en-CA" smtClean="0"/>
-              <a:t>2025-05-08</a:t>
+              <a:t>2025-08-20</a:t>
             </a:fld>
             <a:endParaRPr lang="en-CA"/>
           </a:p>
@@ -604,7 +609,7 @@
           <a:p>
             <a:fld id="{BB28D876-8156-7A44-AEE1-4802FB0B213F}" type="datetimeFigureOut">
               <a:rPr lang="en-CA" smtClean="0"/>
-              <a:t>2025-05-08</a:t>
+              <a:t>2025-08-20</a:t>
             </a:fld>
             <a:endParaRPr lang="en-CA"/>
           </a:p>
@@ -774,7 +779,7 @@
           <a:p>
             <a:fld id="{BB28D876-8156-7A44-AEE1-4802FB0B213F}" type="datetimeFigureOut">
               <a:rPr lang="en-CA" smtClean="0"/>
-              <a:t>2025-05-08</a:t>
+              <a:t>2025-08-20</a:t>
             </a:fld>
             <a:endParaRPr lang="en-CA"/>
           </a:p>
@@ -1020,7 +1025,7 @@
           <a:p>
             <a:fld id="{BB28D876-8156-7A44-AEE1-4802FB0B213F}" type="datetimeFigureOut">
               <a:rPr lang="en-CA" smtClean="0"/>
-              <a:t>2025-05-08</a:t>
+              <a:t>2025-08-20</a:t>
             </a:fld>
             <a:endParaRPr lang="en-CA"/>
           </a:p>
@@ -1252,7 +1257,7 @@
           <a:p>
             <a:fld id="{BB28D876-8156-7A44-AEE1-4802FB0B213F}" type="datetimeFigureOut">
               <a:rPr lang="en-CA" smtClean="0"/>
-              <a:t>2025-05-08</a:t>
+              <a:t>2025-08-20</a:t>
             </a:fld>
             <a:endParaRPr lang="en-CA"/>
           </a:p>
@@ -1619,7 +1624,7 @@
           <a:p>
             <a:fld id="{BB28D876-8156-7A44-AEE1-4802FB0B213F}" type="datetimeFigureOut">
               <a:rPr lang="en-CA" smtClean="0"/>
-              <a:t>2025-05-08</a:t>
+              <a:t>2025-08-20</a:t>
             </a:fld>
             <a:endParaRPr lang="en-CA"/>
           </a:p>
@@ -1737,7 +1742,7 @@
           <a:p>
             <a:fld id="{BB28D876-8156-7A44-AEE1-4802FB0B213F}" type="datetimeFigureOut">
               <a:rPr lang="en-CA" smtClean="0"/>
-              <a:t>2025-05-08</a:t>
+              <a:t>2025-08-20</a:t>
             </a:fld>
             <a:endParaRPr lang="en-CA"/>
           </a:p>
@@ -1832,7 +1837,7 @@
           <a:p>
             <a:fld id="{BB28D876-8156-7A44-AEE1-4802FB0B213F}" type="datetimeFigureOut">
               <a:rPr lang="en-CA" smtClean="0"/>
-              <a:t>2025-05-08</a:t>
+              <a:t>2025-08-20</a:t>
             </a:fld>
             <a:endParaRPr lang="en-CA"/>
           </a:p>
@@ -2109,7 +2114,7 @@
           <a:p>
             <a:fld id="{BB28D876-8156-7A44-AEE1-4802FB0B213F}" type="datetimeFigureOut">
               <a:rPr lang="en-CA" smtClean="0"/>
-              <a:t>2025-05-08</a:t>
+              <a:t>2025-08-20</a:t>
             </a:fld>
             <a:endParaRPr lang="en-CA"/>
           </a:p>
@@ -2366,7 +2371,7 @@
           <a:p>
             <a:fld id="{BB28D876-8156-7A44-AEE1-4802FB0B213F}" type="datetimeFigureOut">
               <a:rPr lang="en-CA" smtClean="0"/>
-              <a:t>2025-05-08</a:t>
+              <a:t>2025-08-20</a:t>
             </a:fld>
             <a:endParaRPr lang="en-CA"/>
           </a:p>
@@ -2579,7 +2584,7 @@
           <a:p>
             <a:fld id="{BB28D876-8156-7A44-AEE1-4802FB0B213F}" type="datetimeFigureOut">
               <a:rPr lang="en-CA" smtClean="0"/>
-              <a:t>2025-05-08</a:t>
+              <a:t>2025-08-20</a:t>
             </a:fld>
             <a:endParaRPr lang="en-CA"/>
           </a:p>
@@ -3003,8 +3008,8 @@
         </p:nvSpPr>
         <p:spPr>
           <a:xfrm>
-            <a:off x="8101322" y="3449215"/>
-            <a:ext cx="5471492" cy="1386508"/>
+            <a:off x="7091917" y="3449215"/>
+            <a:ext cx="7347983" cy="1386508"/>
           </a:xfrm>
           <a:prstGeom prst="roundRect">
             <a:avLst/>
@@ -3037,7 +3042,7 @@
           <a:lstStyle/>
           <a:p>
             <a:pPr algn="ctr"/>
-            <a:endParaRPr lang="en-CA" sz="1350" dirty="0"/>
+            <a:endParaRPr lang="fr-CA" sz="1350" noProof="0" dirty="0"/>
           </a:p>
         </p:txBody>
       </p:sp>
@@ -3055,8 +3060,8 @@
         </p:nvSpPr>
         <p:spPr>
           <a:xfrm>
-            <a:off x="8332407" y="3530763"/>
-            <a:ext cx="5009321" cy="1246495"/>
+            <a:off x="7168116" y="3493129"/>
+            <a:ext cx="7195583" cy="1246495"/>
           </a:xfrm>
           <a:prstGeom prst="rect">
             <a:avLst/>
@@ -3071,11 +3076,11 @@
           <a:p>
             <a:pPr algn="ctr"/>
             <a:r>
-              <a:rPr lang="en-CA" sz="3750" dirty="0">
+              <a:rPr lang="fr-CA" sz="3750" noProof="0" dirty="0">
                 <a:latin typeface="Times New Roman" panose="02020603050405020304" pitchFamily="18" charset="0"/>
                 <a:cs typeface="Times New Roman" panose="02020603050405020304" pitchFamily="18" charset="0"/>
               </a:rPr>
-              <a:t>Study has Approval from REB for Data Reuse</a:t>
+              <a:t>L'étude a reçu l'approbation du CER pour la réutilisation des données</a:t>
             </a:r>
           </a:p>
         </p:txBody>
@@ -3128,7 +3133,7 @@
           <a:lstStyle/>
           <a:p>
             <a:pPr algn="ctr"/>
-            <a:endParaRPr lang="en-CA" sz="1350" dirty="0"/>
+            <a:endParaRPr lang="fr-CA" sz="1350" noProof="0" dirty="0"/>
           </a:p>
         </p:txBody>
       </p:sp>
@@ -3180,7 +3185,7 @@
           <a:lstStyle/>
           <a:p>
             <a:pPr algn="ctr"/>
-            <a:endParaRPr lang="en-CA" sz="1350" dirty="0"/>
+            <a:endParaRPr lang="fr-CA" sz="1350" noProof="0" dirty="0"/>
           </a:p>
         </p:txBody>
       </p:sp>
@@ -3198,8 +3203,8 @@
         </p:nvSpPr>
         <p:spPr>
           <a:xfrm>
-            <a:off x="3355774" y="6684721"/>
-            <a:ext cx="4499789" cy="876664"/>
+            <a:off x="2586034" y="6684721"/>
+            <a:ext cx="6039267" cy="876664"/>
           </a:xfrm>
           <a:prstGeom prst="roundRect">
             <a:avLst/>
@@ -3232,7 +3237,7 @@
           <a:lstStyle/>
           <a:p>
             <a:pPr algn="ctr"/>
-            <a:endParaRPr lang="en-CA" sz="1350" dirty="0"/>
+            <a:endParaRPr lang="fr-CA" sz="1350" noProof="0" dirty="0"/>
           </a:p>
         </p:txBody>
       </p:sp>
@@ -3250,8 +3255,8 @@
         </p:nvSpPr>
         <p:spPr>
           <a:xfrm>
-            <a:off x="3490974" y="6788346"/>
-            <a:ext cx="4229388" cy="669414"/>
+            <a:off x="2586034" y="6784953"/>
+            <a:ext cx="6039267" cy="669414"/>
           </a:xfrm>
           <a:prstGeom prst="rect">
             <a:avLst/>
@@ -3266,11 +3271,11 @@
           <a:p>
             <a:pPr algn="ctr"/>
             <a:r>
-              <a:rPr lang="en-CA" sz="3750" dirty="0">
+              <a:rPr lang="fr-CA" sz="3750" noProof="0" dirty="0">
                 <a:latin typeface="Times New Roman" panose="02020603050405020304" pitchFamily="18" charset="0"/>
                 <a:cs typeface="Times New Roman" panose="02020603050405020304" pitchFamily="18" charset="0"/>
               </a:rPr>
-              <a:t>Get REB Approval</a:t>
+              <a:t>Obtenir l’approbation du CER</a:t>
             </a:r>
           </a:p>
         </p:txBody>
@@ -3289,7 +3294,7 @@
         </p:nvSpPr>
         <p:spPr>
           <a:xfrm>
-            <a:off x="5143279" y="4955254"/>
+            <a:off x="5272253" y="4958203"/>
             <a:ext cx="1779002" cy="861774"/>
           </a:xfrm>
           <a:prstGeom prst="rect">
@@ -3305,11 +3310,11 @@
           <a:p>
             <a:pPr algn="ctr"/>
             <a:r>
-              <a:rPr lang="en-CA" sz="5000" dirty="0">
+              <a:rPr lang="fr-CA" sz="5000" noProof="0" dirty="0">
                 <a:latin typeface="Times New Roman" panose="02020603050405020304" pitchFamily="18" charset="0"/>
                 <a:cs typeface="Times New Roman" panose="02020603050405020304" pitchFamily="18" charset="0"/>
               </a:rPr>
-              <a:t>No</a:t>
+              <a:t>Non</a:t>
             </a:r>
           </a:p>
         </p:txBody>
@@ -3344,11 +3349,11 @@
           <a:p>
             <a:pPr algn="ctr"/>
             <a:r>
-              <a:rPr lang="en-CA" sz="5000" dirty="0">
+              <a:rPr lang="fr-CA" sz="5000" noProof="0" dirty="0">
                 <a:latin typeface="Times New Roman" panose="02020603050405020304" pitchFamily="18" charset="0"/>
                 <a:cs typeface="Times New Roman" panose="02020603050405020304" pitchFamily="18" charset="0"/>
               </a:rPr>
-              <a:t>Yes</a:t>
+              <a:t>Oui</a:t>
             </a:r>
           </a:p>
         </p:txBody>
@@ -3367,8 +3372,8 @@
         </p:nvSpPr>
         <p:spPr>
           <a:xfrm>
-            <a:off x="10867791" y="6684721"/>
-            <a:ext cx="5471492" cy="2884603"/>
+            <a:off x="10219762" y="6684721"/>
+            <a:ext cx="6862120" cy="2884603"/>
           </a:xfrm>
           <a:prstGeom prst="roundRect">
             <a:avLst/>
@@ -3401,7 +3406,7 @@
           <a:lstStyle/>
           <a:p>
             <a:pPr algn="ctr"/>
-            <a:endParaRPr lang="en-CA" sz="1350" dirty="0"/>
+            <a:endParaRPr lang="fr-CA" sz="1350" noProof="0" dirty="0"/>
           </a:p>
         </p:txBody>
       </p:sp>
@@ -3419,8 +3424,8 @@
         </p:nvSpPr>
         <p:spPr>
           <a:xfrm>
-            <a:off x="10867791" y="6874377"/>
-            <a:ext cx="5471492" cy="2400657"/>
+            <a:off x="10195072" y="6816262"/>
+            <a:ext cx="6886810" cy="2400657"/>
           </a:xfrm>
           <a:prstGeom prst="rect">
             <a:avLst/>
@@ -3435,30 +3440,20 @@
           <a:p>
             <a:pPr algn="ctr"/>
             <a:r>
-              <a:rPr lang="en-CA" sz="3750" dirty="0">
+              <a:rPr lang="fr-CA" sz="3750" noProof="0" dirty="0">
                 <a:latin typeface="Times New Roman" panose="02020603050405020304" pitchFamily="18" charset="0"/>
                 <a:cs typeface="Times New Roman" panose="02020603050405020304" pitchFamily="18" charset="0"/>
               </a:rPr>
-              <a:t>Can the Data File be </a:t>
-            </a:r>
-          </a:p>
-          <a:p>
-            <a:pPr algn="ctr"/>
-            <a:r>
-              <a:rPr lang="en-CA" sz="3750" dirty="0">
+              <a:t>Le fichier de données peut-il être 
+Anonymisé en toute sécurité ? 
+</a:t>
+            </a:r>
+            <a:r>
+              <a:rPr lang="fr-CA" sz="2500" noProof="0" dirty="0">
                 <a:latin typeface="Times New Roman" panose="02020603050405020304" pitchFamily="18" charset="0"/>
                 <a:cs typeface="Times New Roman" panose="02020603050405020304" pitchFamily="18" charset="0"/>
               </a:rPr>
-              <a:t>Safely Anonymized? </a:t>
-            </a:r>
-          </a:p>
-          <a:p>
-            <a:r>
-              <a:rPr lang="en-CA" sz="2500" dirty="0">
-                <a:latin typeface="Times New Roman" panose="02020603050405020304" pitchFamily="18" charset="0"/>
-                <a:cs typeface="Times New Roman" panose="02020603050405020304" pitchFamily="18" charset="0"/>
-              </a:rPr>
-              <a:t>(All potentially identifiable information can be removed, such as location, names, intersectionality, etc.)</a:t>
+              <a:t>(Toutes les informations potentiellement identifiables peuvent être supprimées, telles que l’emplacement, les noms, l’intersectionnalité, etc.)</a:t>
             </a:r>
           </a:p>
         </p:txBody>
@@ -3511,7 +3506,7 @@
           <a:lstStyle/>
           <a:p>
             <a:pPr algn="ctr"/>
-            <a:endParaRPr lang="en-CA" sz="1350" dirty="0"/>
+            <a:endParaRPr lang="fr-CA" sz="1350" noProof="0" dirty="0"/>
           </a:p>
         </p:txBody>
       </p:sp>
@@ -3529,7 +3524,7 @@
         </p:nvSpPr>
         <p:spPr>
           <a:xfrm>
-            <a:off x="6625024" y="9708819"/>
+            <a:off x="6474396" y="9710589"/>
             <a:ext cx="1779002" cy="861774"/>
           </a:xfrm>
           <a:prstGeom prst="rect">
@@ -3545,11 +3540,11 @@
           <a:p>
             <a:pPr algn="ctr"/>
             <a:r>
-              <a:rPr lang="en-CA" sz="5000" dirty="0">
+              <a:rPr lang="fr-CA" sz="5000" noProof="0" dirty="0">
                 <a:latin typeface="Times New Roman" panose="02020603050405020304" pitchFamily="18" charset="0"/>
                 <a:cs typeface="Times New Roman" panose="02020603050405020304" pitchFamily="18" charset="0"/>
               </a:rPr>
-              <a:t>No</a:t>
+              <a:t>Non</a:t>
             </a:r>
           </a:p>
         </p:txBody>
@@ -3602,7 +3597,7 @@
           <a:lstStyle/>
           <a:p>
             <a:pPr algn="ctr"/>
-            <a:endParaRPr lang="en-CA" sz="1350" dirty="0"/>
+            <a:endParaRPr lang="fr-CA" sz="1350" noProof="0" dirty="0"/>
           </a:p>
         </p:txBody>
       </p:sp>
@@ -3677,11 +3672,11 @@
           <a:p>
             <a:pPr algn="ctr"/>
             <a:r>
-              <a:rPr lang="en-CA" sz="3750" dirty="0">
+              <a:rPr lang="fr-CA" sz="3750" noProof="0" dirty="0">
                 <a:latin typeface="Times New Roman" panose="02020603050405020304" pitchFamily="18" charset="0"/>
                 <a:cs typeface="Times New Roman" panose="02020603050405020304" pitchFamily="18" charset="0"/>
               </a:rPr>
-              <a:t>Is the Data Already Anonymized?</a:t>
+              <a:t>Les données sont-elles déjà anonymisées ?</a:t>
             </a:r>
           </a:p>
         </p:txBody>
@@ -3700,8 +3695,8 @@
         </p:nvSpPr>
         <p:spPr>
           <a:xfrm rot="16200000">
-            <a:off x="15066039" y="13843604"/>
-            <a:ext cx="1980319" cy="5471493"/>
+            <a:off x="15297124" y="14074688"/>
+            <a:ext cx="1980319" cy="5009323"/>
           </a:xfrm>
           <a:prstGeom prst="leftBrace">
             <a:avLst>
@@ -3734,7 +3729,7 @@
           <a:lstStyle/>
           <a:p>
             <a:pPr algn="ctr"/>
-            <a:endParaRPr lang="en-CA" sz="1350" dirty="0"/>
+            <a:endParaRPr lang="fr-CA" sz="1350" noProof="0" dirty="0"/>
           </a:p>
         </p:txBody>
       </p:sp>
@@ -3752,7 +3747,7 @@
         </p:nvSpPr>
         <p:spPr>
           <a:xfrm>
-            <a:off x="14623799" y="9674888"/>
+            <a:off x="14735147" y="9711441"/>
             <a:ext cx="1779002" cy="861774"/>
           </a:xfrm>
           <a:prstGeom prst="rect">
@@ -3768,11 +3763,11 @@
           <a:p>
             <a:pPr algn="ctr"/>
             <a:r>
-              <a:rPr lang="en-CA" sz="5000" dirty="0">
+              <a:rPr lang="fr-CA" sz="5000" noProof="0" dirty="0">
                 <a:latin typeface="Times New Roman" panose="02020603050405020304" pitchFamily="18" charset="0"/>
                 <a:cs typeface="Times New Roman" panose="02020603050405020304" pitchFamily="18" charset="0"/>
               </a:rPr>
-              <a:t>Yes</a:t>
+              <a:t>Oui</a:t>
             </a:r>
           </a:p>
         </p:txBody>
@@ -3791,8 +3786,8 @@
         </p:nvSpPr>
         <p:spPr>
           <a:xfrm rot="5400000">
-            <a:off x="15066040" y="11011766"/>
-            <a:ext cx="1980319" cy="5471493"/>
+            <a:off x="15297124" y="11242851"/>
+            <a:ext cx="1980319" cy="5009323"/>
           </a:xfrm>
           <a:prstGeom prst="leftBrace">
             <a:avLst>
@@ -3825,7 +3820,7 @@
           <a:lstStyle/>
           <a:p>
             <a:pPr algn="ctr"/>
-            <a:endParaRPr lang="en-CA" sz="1350" dirty="0"/>
+            <a:endParaRPr lang="fr-CA" sz="1350" noProof="0" dirty="0"/>
           </a:p>
         </p:txBody>
       </p:sp>
@@ -3843,7 +3838,7 @@
         </p:nvSpPr>
         <p:spPr>
           <a:xfrm>
-            <a:off x="17336612" y="12945371"/>
+            <a:off x="17481993" y="12966524"/>
             <a:ext cx="1779002" cy="861774"/>
           </a:xfrm>
           <a:prstGeom prst="rect">
@@ -3859,11 +3854,11 @@
           <a:p>
             <a:pPr algn="ctr"/>
             <a:r>
-              <a:rPr lang="en-CA" sz="5000" dirty="0">
+              <a:rPr lang="fr-CA" sz="5000" noProof="0" dirty="0">
                 <a:latin typeface="Times New Roman" panose="02020603050405020304" pitchFamily="18" charset="0"/>
                 <a:cs typeface="Times New Roman" panose="02020603050405020304" pitchFamily="18" charset="0"/>
               </a:rPr>
-              <a:t>Yes</a:t>
+              <a:t>Oui</a:t>
             </a:r>
           </a:p>
         </p:txBody>
@@ -3882,8 +3877,8 @@
         </p:nvSpPr>
         <p:spPr>
           <a:xfrm>
-            <a:off x="10879683" y="14558874"/>
-            <a:ext cx="4946181" cy="1196640"/>
+            <a:off x="11164952" y="14631120"/>
+            <a:ext cx="5235338" cy="1196640"/>
           </a:xfrm>
           <a:prstGeom prst="roundRect">
             <a:avLst/>
@@ -3916,7 +3911,7 @@
           <a:lstStyle/>
           <a:p>
             <a:pPr algn="ctr"/>
-            <a:endParaRPr lang="en-CA" sz="1350" dirty="0"/>
+            <a:endParaRPr lang="fr-CA" sz="1350" noProof="0" dirty="0"/>
           </a:p>
         </p:txBody>
       </p:sp>
@@ -3934,8 +3929,8 @@
         </p:nvSpPr>
         <p:spPr>
           <a:xfrm>
-            <a:off x="10900745" y="14540184"/>
-            <a:ext cx="4839414" cy="1246495"/>
+            <a:off x="10994878" y="14563020"/>
+            <a:ext cx="5471490" cy="1246495"/>
           </a:xfrm>
           <a:prstGeom prst="rect">
             <a:avLst/>
@@ -3950,21 +3945,12 @@
           <a:p>
             <a:pPr algn="ctr"/>
             <a:r>
-              <a:rPr lang="en-CA" sz="3750" dirty="0">
+              <a:rPr lang="fr-CA" sz="3750" noProof="0" dirty="0">
                 <a:latin typeface="Times New Roman" panose="02020603050405020304" pitchFamily="18" charset="0"/>
                 <a:cs typeface="Times New Roman" panose="02020603050405020304" pitchFamily="18" charset="0"/>
               </a:rPr>
-              <a:t>Remove All </a:t>
-            </a:r>
-          </a:p>
-          <a:p>
-            <a:pPr algn="ctr"/>
-            <a:r>
-              <a:rPr lang="en-CA" sz="3750" dirty="0">
-                <a:latin typeface="Times New Roman" panose="02020603050405020304" pitchFamily="18" charset="0"/>
-                <a:cs typeface="Times New Roman" panose="02020603050405020304" pitchFamily="18" charset="0"/>
-              </a:rPr>
-              <a:t>Identifiable Information</a:t>
+              <a:t>Retirez toutes 
+informations identifiables</a:t>
             </a:r>
           </a:p>
         </p:txBody>
@@ -3983,7 +3969,7 @@
         </p:nvSpPr>
         <p:spPr>
           <a:xfrm>
-            <a:off x="12996785" y="13002903"/>
+            <a:off x="13386024" y="12983393"/>
             <a:ext cx="1779002" cy="861774"/>
           </a:xfrm>
           <a:prstGeom prst="rect">
@@ -3999,11 +3985,11 @@
           <a:p>
             <a:pPr algn="ctr"/>
             <a:r>
-              <a:rPr lang="en-CA" sz="5000" dirty="0">
+              <a:rPr lang="fr-CA" sz="5000" noProof="0" dirty="0">
                 <a:latin typeface="Times New Roman" panose="02020603050405020304" pitchFamily="18" charset="0"/>
                 <a:cs typeface="Times New Roman" panose="02020603050405020304" pitchFamily="18" charset="0"/>
               </a:rPr>
-              <a:t>No</a:t>
+              <a:t>Non</a:t>
             </a:r>
           </a:p>
         </p:txBody>
@@ -4063,8 +4049,8 @@
         </p:nvSpPr>
         <p:spPr>
           <a:xfrm>
-            <a:off x="13372452" y="17475487"/>
-            <a:ext cx="5471492" cy="1386508"/>
+            <a:off x="13596933" y="17412766"/>
+            <a:ext cx="5471492" cy="1980319"/>
           </a:xfrm>
           <a:prstGeom prst="roundRect">
             <a:avLst/>
@@ -4097,7 +4083,7 @@
           <a:lstStyle/>
           <a:p>
             <a:pPr algn="ctr"/>
-            <a:endParaRPr lang="en-CA" sz="1350" dirty="0"/>
+            <a:endParaRPr lang="fr-CA" sz="1350" noProof="0" dirty="0"/>
           </a:p>
         </p:txBody>
       </p:sp>
@@ -4115,8 +4101,8 @@
         </p:nvSpPr>
         <p:spPr>
           <a:xfrm>
-            <a:off x="13372452" y="17533019"/>
-            <a:ext cx="5471492" cy="1246495"/>
+            <a:off x="13551537" y="17421684"/>
+            <a:ext cx="5471492" cy="1823576"/>
           </a:xfrm>
           <a:prstGeom prst="rect">
             <a:avLst/>
@@ -4131,11 +4117,11 @@
           <a:p>
             <a:pPr algn="ctr"/>
             <a:r>
-              <a:rPr lang="en-CA" sz="3750" dirty="0">
+              <a:rPr lang="fr-CA" sz="3750" noProof="0" dirty="0">
                 <a:latin typeface="Times New Roman" panose="02020603050405020304" pitchFamily="18" charset="0"/>
                 <a:cs typeface="Times New Roman" panose="02020603050405020304" pitchFamily="18" charset="0"/>
               </a:rPr>
-              <a:t>Ready to Begin Upload Process (with Restrictions)</a:t>
+              <a:t>Prêt à commencer le processus de téléversement (avec restrictions)</a:t>
             </a:r>
           </a:p>
         </p:txBody>
@@ -4154,8 +4140,8 @@
         </p:nvSpPr>
         <p:spPr>
           <a:xfrm>
-            <a:off x="3386804" y="11370845"/>
-            <a:ext cx="6832958" cy="1883116"/>
+            <a:off x="2882192" y="11370845"/>
+            <a:ext cx="7816900" cy="1883116"/>
           </a:xfrm>
           <a:prstGeom prst="roundRect">
             <a:avLst/>
@@ -4188,7 +4174,7 @@
           <a:lstStyle/>
           <a:p>
             <a:pPr algn="ctr"/>
-            <a:endParaRPr lang="en-CA" sz="1350" dirty="0"/>
+            <a:endParaRPr lang="fr-CA" sz="1350" noProof="0" dirty="0"/>
           </a:p>
         </p:txBody>
       </p:sp>
@@ -4206,8 +4192,8 @@
         </p:nvSpPr>
         <p:spPr>
           <a:xfrm>
-            <a:off x="3386804" y="11384336"/>
-            <a:ext cx="6720000" cy="1631216"/>
+            <a:off x="2760708" y="11442107"/>
+            <a:ext cx="8067574" cy="1631216"/>
           </a:xfrm>
           <a:prstGeom prst="rect">
             <a:avLst/>
@@ -4222,21 +4208,19 @@
           <a:p>
             <a:pPr algn="ctr"/>
             <a:r>
-              <a:rPr lang="en-CA" sz="3750" dirty="0">
+              <a:rPr lang="fr-CA" sz="3750" noProof="0" dirty="0">
                 <a:latin typeface="Times New Roman" panose="02020603050405020304" pitchFamily="18" charset="0"/>
                 <a:cs typeface="Times New Roman" panose="02020603050405020304" pitchFamily="18" charset="0"/>
               </a:rPr>
-              <a:t>Data File and Study Results Themselves Cannot be Uploaded! </a:t>
-            </a:r>
-          </a:p>
-          <a:p>
-            <a:pPr algn="ctr"/>
-            <a:r>
-              <a:rPr lang="en-CA" sz="2500" dirty="0">
+              <a:t>Le fichier de données et les résultats de l’étude ne peuvent pas être téléversés ! 
+</a:t>
+            </a:r>
+            <a:r>
+              <a:rPr lang="fr-CA" sz="2500" noProof="0" dirty="0">
                 <a:latin typeface="Times New Roman" panose="02020603050405020304" pitchFamily="18" charset="0"/>
                 <a:cs typeface="Times New Roman" panose="02020603050405020304" pitchFamily="18" charset="0"/>
               </a:rPr>
-              <a:t>(Metadata file could still be uploaded)</a:t>
+              <a:t>(Le fichier de métadonnées peut toujours être téléchargé)</a:t>
             </a:r>
           </a:p>
         </p:txBody>
@@ -4255,8 +4239,8 @@
         </p:nvSpPr>
         <p:spPr>
           <a:xfrm>
-            <a:off x="4058749" y="13862787"/>
-            <a:ext cx="5471492" cy="2884603"/>
+            <a:off x="3284448" y="13862787"/>
+            <a:ext cx="7012387" cy="2884603"/>
           </a:xfrm>
           <a:prstGeom prst="roundRect">
             <a:avLst/>
@@ -4289,7 +4273,7 @@
           <a:lstStyle/>
           <a:p>
             <a:pPr algn="ctr"/>
-            <a:endParaRPr lang="en-CA" sz="1350" dirty="0"/>
+            <a:endParaRPr lang="fr-CA" sz="1350" noProof="0" dirty="0"/>
           </a:p>
         </p:txBody>
       </p:sp>
@@ -4307,8 +4291,8 @@
         </p:nvSpPr>
         <p:spPr>
           <a:xfrm>
-            <a:off x="4058749" y="14052443"/>
-            <a:ext cx="5471492" cy="2400657"/>
+            <a:off x="3284448" y="14033134"/>
+            <a:ext cx="7012387" cy="2400657"/>
           </a:xfrm>
           <a:prstGeom prst="rect">
             <a:avLst/>
@@ -4323,30 +4307,20 @@
           <a:p>
             <a:pPr algn="ctr"/>
             <a:r>
-              <a:rPr lang="en-CA" sz="3750" dirty="0">
+              <a:rPr lang="fr-CA" sz="3750" noProof="0" dirty="0">
                 <a:latin typeface="Times New Roman" panose="02020603050405020304" pitchFamily="18" charset="0"/>
                 <a:cs typeface="Times New Roman" panose="02020603050405020304" pitchFamily="18" charset="0"/>
               </a:rPr>
-              <a:t>Can the Metadata be </a:t>
-            </a:r>
-          </a:p>
-          <a:p>
-            <a:pPr algn="ctr"/>
-            <a:r>
-              <a:rPr lang="en-CA" sz="3750" dirty="0">
+              <a:t>Les métadonnées peuvent-elles être 
+anonymisé en toute sécurité ? 
+</a:t>
+            </a:r>
+            <a:r>
+              <a:rPr lang="fr-CA" sz="2500" noProof="0" dirty="0">
                 <a:latin typeface="Times New Roman" panose="02020603050405020304" pitchFamily="18" charset="0"/>
                 <a:cs typeface="Times New Roman" panose="02020603050405020304" pitchFamily="18" charset="0"/>
               </a:rPr>
-              <a:t>Safely Anonymized? </a:t>
-            </a:r>
-          </a:p>
-          <a:p>
-            <a:r>
-              <a:rPr lang="en-CA" sz="2500" dirty="0">
-                <a:latin typeface="Times New Roman" panose="02020603050405020304" pitchFamily="18" charset="0"/>
-                <a:cs typeface="Times New Roman" panose="02020603050405020304" pitchFamily="18" charset="0"/>
-              </a:rPr>
-              <a:t>(All potentially identifiable information can be removed, such as location, names, intersectionality, etc.)</a:t>
+              <a:t>(Toutes les informations potentiellement identifiables peuvent être supprimées, telles que l’emplacement, les noms, l’intersectionnalité, etc.)</a:t>
             </a:r>
           </a:p>
         </p:txBody>
@@ -4365,7 +4339,7 @@
         </p:nvSpPr>
         <p:spPr>
           <a:xfrm>
-            <a:off x="4967802" y="16937046"/>
+            <a:off x="4855551" y="16930833"/>
             <a:ext cx="1779002" cy="861774"/>
           </a:xfrm>
           <a:prstGeom prst="rect">
@@ -4381,11 +4355,11 @@
           <a:p>
             <a:pPr algn="ctr"/>
             <a:r>
-              <a:rPr lang="en-CA" sz="5000" dirty="0">
+              <a:rPr lang="fr-CA" sz="5000" noProof="0" dirty="0">
                 <a:latin typeface="Times New Roman" panose="02020603050405020304" pitchFamily="18" charset="0"/>
                 <a:cs typeface="Times New Roman" panose="02020603050405020304" pitchFamily="18" charset="0"/>
               </a:rPr>
-              <a:t>No</a:t>
+              <a:t>Non</a:t>
             </a:r>
           </a:p>
         </p:txBody>
@@ -4404,7 +4378,7 @@
         </p:nvSpPr>
         <p:spPr>
           <a:xfrm>
-            <a:off x="9292138" y="16910184"/>
+            <a:off x="9357192" y="16930833"/>
             <a:ext cx="1779002" cy="861774"/>
           </a:xfrm>
           <a:prstGeom prst="rect">
@@ -4420,11 +4394,11 @@
           <a:p>
             <a:pPr algn="ctr"/>
             <a:r>
-              <a:rPr lang="en-CA" sz="5000" dirty="0">
+              <a:rPr lang="fr-CA" sz="5000" noProof="0" dirty="0">
                 <a:latin typeface="Times New Roman" panose="02020603050405020304" pitchFamily="18" charset="0"/>
                 <a:cs typeface="Times New Roman" panose="02020603050405020304" pitchFamily="18" charset="0"/>
               </a:rPr>
-              <a:t>Yes</a:t>
+              <a:t>Oui</a:t>
             </a:r>
           </a:p>
         </p:txBody>
@@ -4443,8 +4417,8 @@
         </p:nvSpPr>
         <p:spPr>
           <a:xfrm>
-            <a:off x="2774181" y="18518576"/>
-            <a:ext cx="4946181" cy="1196640"/>
+            <a:off x="2586032" y="18604896"/>
+            <a:ext cx="5249593" cy="1196640"/>
           </a:xfrm>
           <a:prstGeom prst="roundRect">
             <a:avLst/>
@@ -4477,7 +4451,7 @@
           <a:lstStyle/>
           <a:p>
             <a:pPr algn="ctr"/>
-            <a:endParaRPr lang="en-CA" sz="1350" dirty="0"/>
+            <a:endParaRPr lang="fr-CA" sz="1350" noProof="0" dirty="0"/>
           </a:p>
         </p:txBody>
       </p:sp>
@@ -4495,8 +4469,8 @@
         </p:nvSpPr>
         <p:spPr>
           <a:xfrm>
-            <a:off x="2842811" y="18468721"/>
-            <a:ext cx="4770783" cy="1246495"/>
+            <a:off x="2586034" y="18555041"/>
+            <a:ext cx="5249592" cy="1246495"/>
           </a:xfrm>
           <a:prstGeom prst="rect">
             <a:avLst/>
@@ -4511,11 +4485,11 @@
           <a:p>
             <a:pPr algn="ctr"/>
             <a:r>
-              <a:rPr lang="en-CA" sz="3750" dirty="0">
+              <a:rPr lang="fr-CA" sz="3750" noProof="0" dirty="0">
                 <a:latin typeface="Times New Roman" panose="02020603050405020304" pitchFamily="18" charset="0"/>
                 <a:cs typeface="Times New Roman" panose="02020603050405020304" pitchFamily="18" charset="0"/>
               </a:rPr>
-              <a:t>Do Not Pursue Metadata Sharing</a:t>
+              <a:t>Ne poursuivez pas le partage des métadonnées</a:t>
             </a:r>
           </a:p>
         </p:txBody>
@@ -4577,8 +4551,8 @@
         </p:nvSpPr>
         <p:spPr>
           <a:xfrm>
-            <a:off x="8479818" y="20330713"/>
-            <a:ext cx="4438547" cy="1386508"/>
+            <a:off x="8326766" y="20291301"/>
+            <a:ext cx="4744651" cy="1386508"/>
           </a:xfrm>
           <a:prstGeom prst="roundRect">
             <a:avLst/>
@@ -4611,7 +4585,7 @@
           <a:lstStyle/>
           <a:p>
             <a:pPr algn="ctr"/>
-            <a:endParaRPr lang="en-CA" sz="1350" dirty="0"/>
+            <a:endParaRPr lang="fr-CA" sz="1350" noProof="0" dirty="0"/>
           </a:p>
         </p:txBody>
       </p:sp>
@@ -4629,8 +4603,8 @@
         </p:nvSpPr>
         <p:spPr>
           <a:xfrm>
-            <a:off x="8479818" y="20400719"/>
-            <a:ext cx="4438547" cy="1246495"/>
+            <a:off x="8165211" y="20361307"/>
+            <a:ext cx="4906206" cy="1246495"/>
           </a:xfrm>
           <a:prstGeom prst="rect">
             <a:avLst/>
@@ -4645,11 +4619,11 @@
           <a:p>
             <a:pPr algn="ctr"/>
             <a:r>
-              <a:rPr lang="en-CA" sz="3750" dirty="0">
+              <a:rPr lang="fr-CA" sz="3750" noProof="0" dirty="0">
                 <a:latin typeface="Times New Roman" panose="02020603050405020304" pitchFamily="18" charset="0"/>
                 <a:cs typeface="Times New Roman" panose="02020603050405020304" pitchFamily="18" charset="0"/>
               </a:rPr>
-              <a:t>Ready to Create File in Next Section</a:t>
+              <a:t>Prêt à créer un fichier dans la section suivante</a:t>
             </a:r>
           </a:p>
         </p:txBody>

</xml_diff>